<commit_message>
showcase re-recorded on the P&L variance (PLG-20): new transcript, filed outputs, images; 8/8 seals verify; variance.json hashes to the test constant; README timing and golden description
Co-Authored-By: Claude Opus 5.5 <noreply@anthropic.com>
</commit_message>
<xml_diff>
--- a/showcase/may-26/filed/Management Pack - May-26 SIGNED KL.pptx
+++ b/showcase/may-26/filed/Management Pack - May-26 SIGNED KL.pptx
@@ -3226,7 +3226,7 @@
         </p:nvGraphicFramePr>
         <p:xfrm>
           <a:off x="548640" y="1188720"/>
-          <a:ext cx="7315200" cy="1645919"/>
+          <a:ext cx="7315200" cy="1645920"/>
         </p:xfrm>
         <a:graphic>
           <a:graphicData uri="http://schemas.openxmlformats.org/drawingml/2006/table">
@@ -3238,7 +3238,7 @@
                 <a:gridCol w="5029200"/>
                 <a:gridCol w="2286000"/>
               </a:tblGrid>
-              <a:tr h="274319">
+              <a:tr h="274320">
                 <a:tc>
                   <a:txBody>
                     <a:bodyPr/>
@@ -3249,7 +3249,7 @@
                       </a:pPr>
                     </a:p>
                   </a:txBody>
-                  <a:tcPr/>
+                  <a:tcPr marT="18288" marB="18288"/>
                 </a:tc>
                 <a:tc>
                   <a:txBody>
@@ -3264,10 +3264,10 @@
                       </a:r>
                     </a:p>
                   </a:txBody>
-                  <a:tcPr/>
+                  <a:tcPr marT="18288" marB="18288"/>
                 </a:tc>
               </a:tr>
-              <a:tr h="274319">
+              <a:tr h="274320">
                 <a:tc>
                   <a:txBody>
                     <a:bodyPr/>
@@ -3281,7 +3281,7 @@
                       </a:r>
                     </a:p>
                   </a:txBody>
-                  <a:tcPr/>
+                  <a:tcPr marT="18288" marB="18288"/>
                 </a:tc>
                 <a:tc>
                   <a:txBody>
@@ -3296,10 +3296,10 @@
                       </a:r>
                     </a:p>
                   </a:txBody>
-                  <a:tcPr/>
+                  <a:tcPr marT="18288" marB="18288"/>
                 </a:tc>
               </a:tr>
-              <a:tr h="274319">
+              <a:tr h="274320">
                 <a:tc>
                   <a:txBody>
                     <a:bodyPr/>
@@ -3313,7 +3313,7 @@
                       </a:r>
                     </a:p>
                   </a:txBody>
-                  <a:tcPr/>
+                  <a:tcPr marT="18288" marB="18288"/>
                 </a:tc>
                 <a:tc>
                   <a:txBody>
@@ -3328,10 +3328,10 @@
                       </a:r>
                     </a:p>
                   </a:txBody>
-                  <a:tcPr/>
+                  <a:tcPr marT="18288" marB="18288"/>
                 </a:tc>
               </a:tr>
-              <a:tr h="274319">
+              <a:tr h="274320">
                 <a:tc>
                   <a:txBody>
                     <a:bodyPr/>
@@ -3345,7 +3345,7 @@
                       </a:r>
                     </a:p>
                   </a:txBody>
-                  <a:tcPr/>
+                  <a:tcPr marT="18288" marB="18288"/>
                 </a:tc>
                 <a:tc>
                   <a:txBody>
@@ -3360,10 +3360,10 @@
                       </a:r>
                     </a:p>
                   </a:txBody>
-                  <a:tcPr/>
+                  <a:tcPr marT="18288" marB="18288"/>
                 </a:tc>
               </a:tr>
-              <a:tr h="274319">
+              <a:tr h="274320">
                 <a:tc>
                   <a:txBody>
                     <a:bodyPr/>
@@ -3377,7 +3377,7 @@
                       </a:r>
                     </a:p>
                   </a:txBody>
-                  <a:tcPr/>
+                  <a:tcPr marT="18288" marB="18288"/>
                 </a:tc>
                 <a:tc>
                   <a:txBody>
@@ -3392,10 +3392,10 @@
                       </a:r>
                     </a:p>
                   </a:txBody>
-                  <a:tcPr/>
+                  <a:tcPr marT="18288" marB="18288"/>
                 </a:tc>
               </a:tr>
-              <a:tr h="274324">
+              <a:tr h="274320">
                 <a:tc>
                   <a:txBody>
                     <a:bodyPr/>
@@ -3409,7 +3409,7 @@
                       </a:r>
                     </a:p>
                   </a:txBody>
-                  <a:tcPr/>
+                  <a:tcPr marT="18288" marB="18288"/>
                 </a:tc>
                 <a:tc>
                   <a:txBody>
@@ -3421,7 +3421,7 @@
                       </a:pPr>
                     </a:p>
                   </a:txBody>
-                  <a:tcPr/>
+                  <a:tcPr marT="18288" marB="18288"/>
                 </a:tc>
               </a:tr>
             </a:tbl>
@@ -3491,7 +3491,7 @@
         </p:nvGraphicFramePr>
         <p:xfrm>
           <a:off x="548640" y="1188720"/>
-          <a:ext cx="9966960" cy="3840480"/>
+          <a:ext cx="9692640" cy="4114800"/>
         </p:xfrm>
         <a:graphic>
           <a:graphicData uri="http://schemas.openxmlformats.org/drawingml/2006/table">
@@ -3500,1260 +3500,1869 @@
                 <a:tableStyleId>{5C22544A-7EE6-4342-B048-85BDC9FD1C3A}</a:tableStyleId>
               </a:tblPr>
               <a:tblGrid>
-                <a:gridCol w="3840480"/>
-                <a:gridCol w="1371600"/>
-                <a:gridCol w="1371600"/>
-                <a:gridCol w="1371600"/>
+                <a:gridCol w="3657600"/>
                 <a:gridCol w="1188720"/>
+                <a:gridCol w="1188720"/>
+                <a:gridCol w="1188720"/>
+                <a:gridCol w="1005840"/>
+                <a:gridCol w="640080"/>
                 <a:gridCol w="822960"/>
               </a:tblGrid>
-              <a:tr h="274320">
-                <a:tc>
-                  <a:txBody>
-                    <a:bodyPr/>
-                    <a:lstStyle/>
-                    <a:p>
-                      <a:pPr>
-                        <a:defRPr sz="1100" b="1"/>
+              <a:tr h="228600">
+                <a:tc>
+                  <a:txBody>
+                    <a:bodyPr/>
+                    <a:lstStyle/>
+                    <a:p>
+                      <a:pPr>
+                        <a:defRPr sz="1000" b="1"/>
                       </a:pPr>
                       <a:r>
                         <a:t>Line</a:t>
                       </a:r>
                     </a:p>
                   </a:txBody>
-                  <a:tcPr/>
-                </a:tc>
-                <a:tc>
-                  <a:txBody>
-                    <a:bodyPr/>
-                    <a:lstStyle/>
-                    <a:p>
-                      <a:pPr>
-                        <a:defRPr sz="1100" b="1"/>
+                  <a:tcPr marT="18288" marB="18288"/>
+                </a:tc>
+                <a:tc>
+                  <a:txBody>
+                    <a:bodyPr/>
+                    <a:lstStyle/>
+                    <a:p>
+                      <a:pPr>
+                        <a:defRPr sz="1000" b="1"/>
                       </a:pPr>
                       <a:r>
                         <a:t>Actual</a:t>
                       </a:r>
                     </a:p>
                   </a:txBody>
-                  <a:tcPr/>
-                </a:tc>
-                <a:tc>
-                  <a:txBody>
-                    <a:bodyPr/>
-                    <a:lstStyle/>
-                    <a:p>
-                      <a:pPr>
-                        <a:defRPr sz="1100" b="1"/>
+                  <a:tcPr marT="18288" marB="18288"/>
+                </a:tc>
+                <a:tc>
+                  <a:txBody>
+                    <a:bodyPr/>
+                    <a:lstStyle/>
+                    <a:p>
+                      <a:pPr>
+                        <a:defRPr sz="1000" b="1"/>
                       </a:pPr>
                       <a:r>
                         <a:t>Budget</a:t>
                       </a:r>
                     </a:p>
                   </a:txBody>
-                  <a:tcPr/>
-                </a:tc>
-                <a:tc>
-                  <a:txBody>
-                    <a:bodyPr/>
-                    <a:lstStyle/>
-                    <a:p>
-                      <a:pPr>
-                        <a:defRPr sz="1100" b="1"/>
+                  <a:tcPr marT="18288" marB="18288"/>
+                </a:tc>
+                <a:tc>
+                  <a:txBody>
+                    <a:bodyPr/>
+                    <a:lstStyle/>
+                    <a:p>
+                      <a:pPr>
+                        <a:defRPr sz="1000" b="1"/>
                       </a:pPr>
                       <a:r>
                         <a:t>Var</a:t>
                       </a:r>
                     </a:p>
                   </a:txBody>
-                  <a:tcPr/>
-                </a:tc>
-                <a:tc>
-                  <a:txBody>
-                    <a:bodyPr/>
-                    <a:lstStyle/>
-                    <a:p>
-                      <a:pPr>
-                        <a:defRPr sz="1100" b="1"/>
+                  <a:tcPr marT="18288" marB="18288"/>
+                </a:tc>
+                <a:tc>
+                  <a:txBody>
+                    <a:bodyPr/>
+                    <a:lstStyle/>
+                    <a:p>
+                      <a:pPr>
+                        <a:defRPr sz="1000" b="1"/>
                       </a:pPr>
                       <a:r>
                         <a:t>Var %</a:t>
                       </a:r>
                     </a:p>
                   </a:txBody>
-                  <a:tcPr/>
-                </a:tc>
-                <a:tc>
-                  <a:txBody>
-                    <a:bodyPr/>
-                    <a:lstStyle/>
-                    <a:p>
-                      <a:pPr>
-                        <a:defRPr sz="1100" b="1"/>
-                      </a:pPr>
-                    </a:p>
-                  </a:txBody>
-                  <a:tcPr/>
+                  <a:tcPr marT="18288" marB="18288"/>
+                </a:tc>
+                <a:tc>
+                  <a:txBody>
+                    <a:bodyPr/>
+                    <a:lstStyle/>
+                    <a:p>
+                      <a:pPr>
+                        <a:defRPr sz="1000" b="1"/>
+                      </a:pPr>
+                      <a:r>
+                        <a:t>F/A</a:t>
+                      </a:r>
+                    </a:p>
+                  </a:txBody>
+                  <a:tcPr marT="18288" marB="18288"/>
+                </a:tc>
+                <a:tc>
+                  <a:txBody>
+                    <a:bodyPr/>
+                    <a:lstStyle/>
+                    <a:p>
+                      <a:pPr>
+                        <a:defRPr sz="1000" b="1"/>
+                      </a:pPr>
+                    </a:p>
+                  </a:txBody>
+                  <a:tcPr marT="18288" marB="18288"/>
                 </a:tc>
               </a:tr>
-              <a:tr h="274320">
-                <a:tc>
-                  <a:txBody>
-                    <a:bodyPr/>
-                    <a:lstStyle/>
-                    <a:p>
-                      <a:pPr>
-                        <a:defRPr sz="1100" b="0"/>
+              <a:tr h="228600">
+                <a:tc>
+                  <a:txBody>
+                    <a:bodyPr/>
+                    <a:lstStyle/>
+                    <a:p>
+                      <a:pPr>
+                        <a:defRPr sz="1000" b="0"/>
                       </a:pPr>
                       <a:r>
                         <a:t>Facilities &amp; Safety Supplies</a:t>
                       </a:r>
                     </a:p>
                   </a:txBody>
-                  <a:tcPr/>
-                </a:tc>
-                <a:tc>
-                  <a:txBody>
-                    <a:bodyPr/>
-                    <a:lstStyle/>
-                    <a:p>
-                      <a:pPr>
-                        <a:defRPr sz="1100" b="0"/>
+                  <a:tcPr marT="18288" marB="18288"/>
+                </a:tc>
+                <a:tc>
+                  <a:txBody>
+                    <a:bodyPr/>
+                    <a:lstStyle/>
+                    <a:p>
+                      <a:pPr>
+                        <a:defRPr sz="1000" b="0"/>
                       </a:pPr>
                       <a:r>
                         <a:t>8,343</a:t>
                       </a:r>
                     </a:p>
                   </a:txBody>
-                  <a:tcPr/>
-                </a:tc>
-                <a:tc>
-                  <a:txBody>
-                    <a:bodyPr/>
-                    <a:lstStyle/>
-                    <a:p>
-                      <a:pPr>
-                        <a:defRPr sz="1100" b="0"/>
+                  <a:tcPr marT="18288" marB="18288"/>
+                </a:tc>
+                <a:tc>
+                  <a:txBody>
+                    <a:bodyPr/>
+                    <a:lstStyle/>
+                    <a:p>
+                      <a:pPr>
+                        <a:defRPr sz="1000" b="0"/>
                       </a:pPr>
                       <a:r>
                         <a:t>8,216</a:t>
                       </a:r>
                     </a:p>
                   </a:txBody>
-                  <a:tcPr/>
-                </a:tc>
-                <a:tc>
-                  <a:txBody>
-                    <a:bodyPr/>
-                    <a:lstStyle/>
-                    <a:p>
-                      <a:pPr>
-                        <a:defRPr sz="1100" b="0"/>
+                  <a:tcPr marT="18288" marB="18288"/>
+                </a:tc>
+                <a:tc>
+                  <a:txBody>
+                    <a:bodyPr/>
+                    <a:lstStyle/>
+                    <a:p>
+                      <a:pPr>
+                        <a:defRPr sz="1000" b="0"/>
                       </a:pPr>
                       <a:r>
                         <a:t>+127.0</a:t>
                       </a:r>
                     </a:p>
                   </a:txBody>
-                  <a:tcPr/>
-                </a:tc>
-                <a:tc>
-                  <a:txBody>
-                    <a:bodyPr/>
-                    <a:lstStyle/>
-                    <a:p>
-                      <a:pPr>
-                        <a:defRPr sz="1100" b="0"/>
+                  <a:tcPr marT="18288" marB="18288"/>
+                </a:tc>
+                <a:tc>
+                  <a:txBody>
+                    <a:bodyPr/>
+                    <a:lstStyle/>
+                    <a:p>
+                      <a:pPr>
+                        <a:defRPr sz="1000" b="0"/>
                       </a:pPr>
                       <a:r>
                         <a:t>+1.5%</a:t>
                       </a:r>
                     </a:p>
                   </a:txBody>
-                  <a:tcPr/>
-                </a:tc>
-                <a:tc>
-                  <a:txBody>
-                    <a:bodyPr/>
-                    <a:lstStyle/>
-                    <a:p>
-                      <a:pPr>
-                        <a:defRPr sz="1100" b="0"/>
+                  <a:tcPr marT="18288" marB="18288"/>
+                </a:tc>
+                <a:tc>
+                  <a:txBody>
+                    <a:bodyPr/>
+                    <a:lstStyle/>
+                    <a:p>
+                      <a:pPr>
+                        <a:defRPr sz="1000" b="0"/>
+                      </a:pPr>
+                      <a:r>
+                        <a:t>F</a:t>
+                      </a:r>
+                    </a:p>
+                  </a:txBody>
+                  <a:tcPr marT="18288" marB="18288"/>
+                </a:tc>
+                <a:tc>
+                  <a:txBody>
+                    <a:bodyPr/>
+                    <a:lstStyle/>
+                    <a:p>
+                      <a:pPr>
+                        <a:defRPr sz="1000" b="0"/>
                       </a:pPr>
                       <a:r>
                         <a:t>FLAG</a:t>
                       </a:r>
                     </a:p>
                   </a:txBody>
-                  <a:tcPr/>
+                  <a:tcPr marT="18288" marB="18288"/>
                 </a:tc>
               </a:tr>
-              <a:tr h="274320">
-                <a:tc>
-                  <a:txBody>
-                    <a:bodyPr/>
-                    <a:lstStyle/>
-                    <a:p>
-                      <a:pPr>
-                        <a:defRPr sz="1100" b="0"/>
+              <a:tr h="228600">
+                <a:tc>
+                  <a:txBody>
+                    <a:bodyPr/>
+                    <a:lstStyle/>
+                    <a:p>
+                      <a:pPr>
+                        <a:defRPr sz="1000" b="0"/>
                       </a:pPr>
                       <a:r>
                         <a:t>Industrial Consumables &amp; Packaging</a:t>
                       </a:r>
                     </a:p>
                   </a:txBody>
-                  <a:tcPr/>
-                </a:tc>
-                <a:tc>
-                  <a:txBody>
-                    <a:bodyPr/>
-                    <a:lstStyle/>
-                    <a:p>
-                      <a:pPr>
-                        <a:defRPr sz="1100" b="0"/>
+                  <a:tcPr marT="18288" marB="18288"/>
+                </a:tc>
+                <a:tc>
+                  <a:txBody>
+                    <a:bodyPr/>
+                    <a:lstStyle/>
+                    <a:p>
+                      <a:pPr>
+                        <a:defRPr sz="1000" b="0"/>
                       </a:pPr>
                       <a:r>
                         <a:t>8,464</a:t>
                       </a:r>
                     </a:p>
                   </a:txBody>
-                  <a:tcPr/>
-                </a:tc>
-                <a:tc>
-                  <a:txBody>
-                    <a:bodyPr/>
-                    <a:lstStyle/>
-                    <a:p>
-                      <a:pPr>
-                        <a:defRPr sz="1100" b="0"/>
+                  <a:tcPr marT="18288" marB="18288"/>
+                </a:tc>
+                <a:tc>
+                  <a:txBody>
+                    <a:bodyPr/>
+                    <a:lstStyle/>
+                    <a:p>
+                      <a:pPr>
+                        <a:defRPr sz="1000" b="0"/>
                       </a:pPr>
                       <a:r>
                         <a:t>8,361</a:t>
                       </a:r>
                     </a:p>
                   </a:txBody>
-                  <a:tcPr/>
-                </a:tc>
-                <a:tc>
-                  <a:txBody>
-                    <a:bodyPr/>
-                    <a:lstStyle/>
-                    <a:p>
-                      <a:pPr>
-                        <a:defRPr sz="1100" b="0"/>
+                  <a:tcPr marT="18288" marB="18288"/>
+                </a:tc>
+                <a:tc>
+                  <a:txBody>
+                    <a:bodyPr/>
+                    <a:lstStyle/>
+                    <a:p>
+                      <a:pPr>
+                        <a:defRPr sz="1000" b="0"/>
                       </a:pPr>
                       <a:r>
                         <a:t>+103.0</a:t>
                       </a:r>
                     </a:p>
                   </a:txBody>
-                  <a:tcPr/>
-                </a:tc>
-                <a:tc>
-                  <a:txBody>
-                    <a:bodyPr/>
-                    <a:lstStyle/>
-                    <a:p>
-                      <a:pPr>
-                        <a:defRPr sz="1100" b="0"/>
+                  <a:tcPr marT="18288" marB="18288"/>
+                </a:tc>
+                <a:tc>
+                  <a:txBody>
+                    <a:bodyPr/>
+                    <a:lstStyle/>
+                    <a:p>
+                      <a:pPr>
+                        <a:defRPr sz="1000" b="0"/>
                       </a:pPr>
                       <a:r>
                         <a:t>+1.2%</a:t>
                       </a:r>
                     </a:p>
                   </a:txBody>
-                  <a:tcPr/>
-                </a:tc>
-                <a:tc>
-                  <a:txBody>
-                    <a:bodyPr/>
-                    <a:lstStyle/>
-                    <a:p>
-                      <a:pPr>
-                        <a:defRPr sz="1100" b="0"/>
+                  <a:tcPr marT="18288" marB="18288"/>
+                </a:tc>
+                <a:tc>
+                  <a:txBody>
+                    <a:bodyPr/>
+                    <a:lstStyle/>
+                    <a:p>
+                      <a:pPr>
+                        <a:defRPr sz="1000" b="0"/>
+                      </a:pPr>
+                      <a:r>
+                        <a:t>F</a:t>
+                      </a:r>
+                    </a:p>
+                  </a:txBody>
+                  <a:tcPr marT="18288" marB="18288"/>
+                </a:tc>
+                <a:tc>
+                  <a:txBody>
+                    <a:bodyPr/>
+                    <a:lstStyle/>
+                    <a:p>
+                      <a:pPr>
+                        <a:defRPr sz="1000" b="0"/>
                       </a:pPr>
                       <a:r>
                         <a:t>FLAG</a:t>
                       </a:r>
                     </a:p>
                   </a:txBody>
-                  <a:tcPr/>
+                  <a:tcPr marT="18288" marB="18288"/>
                 </a:tc>
               </a:tr>
-              <a:tr h="274320">
-                <a:tc>
-                  <a:txBody>
-                    <a:bodyPr/>
-                    <a:lstStyle/>
-                    <a:p>
-                      <a:pPr>
-                        <a:defRPr sz="1100" b="0"/>
+              <a:tr h="228600">
+                <a:tc>
+                  <a:txBody>
+                    <a:bodyPr/>
+                    <a:lstStyle/>
+                    <a:p>
+                      <a:pPr>
+                        <a:defRPr sz="1000" b="0"/>
                       </a:pPr>
                       <a:r>
                         <a:t>Office &amp; Print Solutions</a:t>
                       </a:r>
                     </a:p>
                   </a:txBody>
-                  <a:tcPr/>
-                </a:tc>
-                <a:tc>
-                  <a:txBody>
-                    <a:bodyPr/>
-                    <a:lstStyle/>
-                    <a:p>
-                      <a:pPr>
-                        <a:defRPr sz="1100" b="0"/>
+                  <a:tcPr marT="18288" marB="18288"/>
+                </a:tc>
+                <a:tc>
+                  <a:txBody>
+                    <a:bodyPr/>
+                    <a:lstStyle/>
+                    <a:p>
+                      <a:pPr>
+                        <a:defRPr sz="1000" b="0"/>
                       </a:pPr>
                       <a:r>
                         <a:t>4,256</a:t>
                       </a:r>
                     </a:p>
                   </a:txBody>
-                  <a:tcPr/>
-                </a:tc>
-                <a:tc>
-                  <a:txBody>
-                    <a:bodyPr/>
-                    <a:lstStyle/>
-                    <a:p>
-                      <a:pPr>
-                        <a:defRPr sz="1100" b="0"/>
+                  <a:tcPr marT="18288" marB="18288"/>
+                </a:tc>
+                <a:tc>
+                  <a:txBody>
+                    <a:bodyPr/>
+                    <a:lstStyle/>
+                    <a:p>
+                      <a:pPr>
+                        <a:defRPr sz="1000" b="0"/>
                       </a:pPr>
                       <a:r>
                         <a:t>4,176</a:t>
                       </a:r>
                     </a:p>
                   </a:txBody>
-                  <a:tcPr/>
-                </a:tc>
-                <a:tc>
-                  <a:txBody>
-                    <a:bodyPr/>
-                    <a:lstStyle/>
-                    <a:p>
-                      <a:pPr>
-                        <a:defRPr sz="1100" b="0"/>
+                  <a:tcPr marT="18288" marB="18288"/>
+                </a:tc>
+                <a:tc>
+                  <a:txBody>
+                    <a:bodyPr/>
+                    <a:lstStyle/>
+                    <a:p>
+                      <a:pPr>
+                        <a:defRPr sz="1000" b="0"/>
                       </a:pPr>
                       <a:r>
                         <a:t>+80.0</a:t>
                       </a:r>
                     </a:p>
                   </a:txBody>
-                  <a:tcPr/>
-                </a:tc>
-                <a:tc>
-                  <a:txBody>
-                    <a:bodyPr/>
-                    <a:lstStyle/>
-                    <a:p>
-                      <a:pPr>
-                        <a:defRPr sz="1100" b="0"/>
+                  <a:tcPr marT="18288" marB="18288"/>
+                </a:tc>
+                <a:tc>
+                  <a:txBody>
+                    <a:bodyPr/>
+                    <a:lstStyle/>
+                    <a:p>
+                      <a:pPr>
+                        <a:defRPr sz="1000" b="0"/>
                       </a:pPr>
                       <a:r>
                         <a:t>+1.9%</a:t>
                       </a:r>
                     </a:p>
                   </a:txBody>
-                  <a:tcPr/>
-                </a:tc>
-                <a:tc>
-                  <a:txBody>
-                    <a:bodyPr/>
-                    <a:lstStyle/>
-                    <a:p>
-                      <a:pPr>
-                        <a:defRPr sz="1100" b="0"/>
-                      </a:pPr>
-                    </a:p>
-                  </a:txBody>
-                  <a:tcPr/>
+                  <a:tcPr marT="18288" marB="18288"/>
+                </a:tc>
+                <a:tc>
+                  <a:txBody>
+                    <a:bodyPr/>
+                    <a:lstStyle/>
+                    <a:p>
+                      <a:pPr>
+                        <a:defRPr sz="1000" b="0"/>
+                      </a:pPr>
+                      <a:r>
+                        <a:t>F</a:t>
+                      </a:r>
+                    </a:p>
+                  </a:txBody>
+                  <a:tcPr marT="18288" marB="18288"/>
+                </a:tc>
+                <a:tc>
+                  <a:txBody>
+                    <a:bodyPr/>
+                    <a:lstStyle/>
+                    <a:p>
+                      <a:pPr>
+                        <a:defRPr sz="1000" b="0"/>
+                      </a:pPr>
+                    </a:p>
+                  </a:txBody>
+                  <a:tcPr marT="18288" marB="18288"/>
                 </a:tc>
               </a:tr>
-              <a:tr h="274320">
-                <a:tc>
-                  <a:txBody>
-                    <a:bodyPr/>
-                    <a:lstStyle/>
-                    <a:p>
-                      <a:pPr>
-                        <a:defRPr sz="1100" b="0"/>
+              <a:tr h="228600">
+                <a:tc>
+                  <a:txBody>
+                    <a:bodyPr/>
+                    <a:lstStyle/>
+                    <a:p>
+                      <a:pPr>
+                        <a:defRPr sz="1000" b="1"/>
+                      </a:pPr>
+                      <a:r>
+                        <a:t>Total revenue</a:t>
+                      </a:r>
+                    </a:p>
+                  </a:txBody>
+                  <a:tcPr marT="18288" marB="18288"/>
+                </a:tc>
+                <a:tc>
+                  <a:txBody>
+                    <a:bodyPr/>
+                    <a:lstStyle/>
+                    <a:p>
+                      <a:pPr>
+                        <a:defRPr sz="1000" b="1"/>
+                      </a:pPr>
+                      <a:r>
+                        <a:t>21,063</a:t>
+                      </a:r>
+                    </a:p>
+                  </a:txBody>
+                  <a:tcPr marT="18288" marB="18288"/>
+                </a:tc>
+                <a:tc>
+                  <a:txBody>
+                    <a:bodyPr/>
+                    <a:lstStyle/>
+                    <a:p>
+                      <a:pPr>
+                        <a:defRPr sz="1000" b="1"/>
+                      </a:pPr>
+                      <a:r>
+                        <a:t>20,753</a:t>
+                      </a:r>
+                    </a:p>
+                  </a:txBody>
+                  <a:tcPr marT="18288" marB="18288"/>
+                </a:tc>
+                <a:tc>
+                  <a:txBody>
+                    <a:bodyPr/>
+                    <a:lstStyle/>
+                    <a:p>
+                      <a:pPr>
+                        <a:defRPr sz="1000" b="1"/>
+                      </a:pPr>
+                      <a:r>
+                        <a:t>+310.0</a:t>
+                      </a:r>
+                    </a:p>
+                  </a:txBody>
+                  <a:tcPr marT="18288" marB="18288"/>
+                </a:tc>
+                <a:tc>
+                  <a:txBody>
+                    <a:bodyPr/>
+                    <a:lstStyle/>
+                    <a:p>
+                      <a:pPr>
+                        <a:defRPr sz="1000" b="1"/>
+                      </a:pPr>
+                    </a:p>
+                  </a:txBody>
+                  <a:tcPr marT="18288" marB="18288"/>
+                </a:tc>
+                <a:tc>
+                  <a:txBody>
+                    <a:bodyPr/>
+                    <a:lstStyle/>
+                    <a:p>
+                      <a:pPr>
+                        <a:defRPr sz="1000" b="1"/>
+                      </a:pPr>
+                      <a:r>
+                        <a:t>F</a:t>
+                      </a:r>
+                    </a:p>
+                  </a:txBody>
+                  <a:tcPr marT="18288" marB="18288"/>
+                </a:tc>
+                <a:tc>
+                  <a:txBody>
+                    <a:bodyPr/>
+                    <a:lstStyle/>
+                    <a:p>
+                      <a:pPr>
+                        <a:defRPr sz="1000" b="1"/>
+                      </a:pPr>
+                    </a:p>
+                  </a:txBody>
+                  <a:tcPr marT="18288" marB="18288"/>
+                </a:tc>
+              </a:tr>
+              <a:tr h="228600">
+                <a:tc>
+                  <a:txBody>
+                    <a:bodyPr/>
+                    <a:lstStyle/>
+                    <a:p>
+                      <a:pPr>
+                        <a:defRPr sz="1000" b="0"/>
                       </a:pPr>
                       <a:r>
                         <a:t>Cost of goods sold</a:t>
                       </a:r>
                     </a:p>
                   </a:txBody>
-                  <a:tcPr/>
-                </a:tc>
-                <a:tc>
-                  <a:txBody>
-                    <a:bodyPr/>
-                    <a:lstStyle/>
-                    <a:p>
-                      <a:pPr>
-                        <a:defRPr sz="1100" b="0"/>
+                  <a:tcPr marT="18288" marB="18288"/>
+                </a:tc>
+                <a:tc>
+                  <a:txBody>
+                    <a:bodyPr/>
+                    <a:lstStyle/>
+                    <a:p>
+                      <a:pPr>
+                        <a:defRPr sz="1000" b="0"/>
                       </a:pPr>
                       <a:r>
                         <a:t>15,843</a:t>
                       </a:r>
                     </a:p>
                   </a:txBody>
-                  <a:tcPr/>
-                </a:tc>
-                <a:tc>
-                  <a:txBody>
-                    <a:bodyPr/>
-                    <a:lstStyle/>
-                    <a:p>
-                      <a:pPr>
-                        <a:defRPr sz="1100" b="0"/>
+                  <a:tcPr marT="18288" marB="18288"/>
+                </a:tc>
+                <a:tc>
+                  <a:txBody>
+                    <a:bodyPr/>
+                    <a:lstStyle/>
+                    <a:p>
+                      <a:pPr>
+                        <a:defRPr sz="1000" b="0"/>
                       </a:pPr>
                       <a:r>
                         <a:t>15,599</a:t>
                       </a:r>
                     </a:p>
                   </a:txBody>
-                  <a:tcPr/>
-                </a:tc>
-                <a:tc>
-                  <a:txBody>
-                    <a:bodyPr/>
-                    <a:lstStyle/>
-                    <a:p>
-                      <a:pPr>
-                        <a:defRPr sz="1100" b="0"/>
+                  <a:tcPr marT="18288" marB="18288"/>
+                </a:tc>
+                <a:tc>
+                  <a:txBody>
+                    <a:bodyPr/>
+                    <a:lstStyle/>
+                    <a:p>
+                      <a:pPr>
+                        <a:defRPr sz="1000" b="0"/>
                       </a:pPr>
                       <a:r>
                         <a:t>+244.0</a:t>
                       </a:r>
                     </a:p>
                   </a:txBody>
-                  <a:tcPr/>
-                </a:tc>
-                <a:tc>
-                  <a:txBody>
-                    <a:bodyPr/>
-                    <a:lstStyle/>
-                    <a:p>
-                      <a:pPr>
-                        <a:defRPr sz="1100" b="0"/>
+                  <a:tcPr marT="18288" marB="18288"/>
+                </a:tc>
+                <a:tc>
+                  <a:txBody>
+                    <a:bodyPr/>
+                    <a:lstStyle/>
+                    <a:p>
+                      <a:pPr>
+                        <a:defRPr sz="1000" b="0"/>
                       </a:pPr>
                       <a:r>
                         <a:t>+1.6%</a:t>
                       </a:r>
                     </a:p>
                   </a:txBody>
-                  <a:tcPr/>
-                </a:tc>
-                <a:tc>
-                  <a:txBody>
-                    <a:bodyPr/>
-                    <a:lstStyle/>
-                    <a:p>
-                      <a:pPr>
-                        <a:defRPr sz="1100" b="0"/>
+                  <a:tcPr marT="18288" marB="18288"/>
+                </a:tc>
+                <a:tc>
+                  <a:txBody>
+                    <a:bodyPr/>
+                    <a:lstStyle/>
+                    <a:p>
+                      <a:pPr>
+                        <a:defRPr sz="1000" b="0"/>
+                      </a:pPr>
+                      <a:r>
+                        <a:t>A</a:t>
+                      </a:r>
+                    </a:p>
+                  </a:txBody>
+                  <a:tcPr marT="18288" marB="18288"/>
+                </a:tc>
+                <a:tc>
+                  <a:txBody>
+                    <a:bodyPr/>
+                    <a:lstStyle/>
+                    <a:p>
+                      <a:pPr>
+                        <a:defRPr sz="1000" b="0"/>
                       </a:pPr>
                       <a:r>
                         <a:t>FLAG</a:t>
                       </a:r>
                     </a:p>
                   </a:txBody>
-                  <a:tcPr/>
+                  <a:tcPr marT="18288" marB="18288"/>
                 </a:tc>
               </a:tr>
-              <a:tr h="274320">
-                <a:tc>
-                  <a:txBody>
-                    <a:bodyPr/>
-                    <a:lstStyle/>
-                    <a:p>
-                      <a:pPr>
-                        <a:defRPr sz="1100" b="0"/>
+              <a:tr h="228600">
+                <a:tc>
+                  <a:txBody>
+                    <a:bodyPr/>
+                    <a:lstStyle/>
+                    <a:p>
+                      <a:pPr>
+                        <a:defRPr sz="1000" b="1"/>
+                      </a:pPr>
+                      <a:r>
+                        <a:t>Gross margin</a:t>
+                      </a:r>
+                    </a:p>
+                  </a:txBody>
+                  <a:tcPr marT="18288" marB="18288"/>
+                </a:tc>
+                <a:tc>
+                  <a:txBody>
+                    <a:bodyPr/>
+                    <a:lstStyle/>
+                    <a:p>
+                      <a:pPr>
+                        <a:defRPr sz="1000" b="1"/>
+                      </a:pPr>
+                      <a:r>
+                        <a:t>5,220</a:t>
+                      </a:r>
+                    </a:p>
+                  </a:txBody>
+                  <a:tcPr marT="18288" marB="18288"/>
+                </a:tc>
+                <a:tc>
+                  <a:txBody>
+                    <a:bodyPr/>
+                    <a:lstStyle/>
+                    <a:p>
+                      <a:pPr>
+                        <a:defRPr sz="1000" b="1"/>
+                      </a:pPr>
+                      <a:r>
+                        <a:t>5,154</a:t>
+                      </a:r>
+                    </a:p>
+                  </a:txBody>
+                  <a:tcPr marT="18288" marB="18288"/>
+                </a:tc>
+                <a:tc>
+                  <a:txBody>
+                    <a:bodyPr/>
+                    <a:lstStyle/>
+                    <a:p>
+                      <a:pPr>
+                        <a:defRPr sz="1000" b="1"/>
+                      </a:pPr>
+                      <a:r>
+                        <a:t>+66.0</a:t>
+                      </a:r>
+                    </a:p>
+                  </a:txBody>
+                  <a:tcPr marT="18288" marB="18288"/>
+                </a:tc>
+                <a:tc>
+                  <a:txBody>
+                    <a:bodyPr/>
+                    <a:lstStyle/>
+                    <a:p>
+                      <a:pPr>
+                        <a:defRPr sz="1000" b="1"/>
+                      </a:pPr>
+                    </a:p>
+                  </a:txBody>
+                  <a:tcPr marT="18288" marB="18288"/>
+                </a:tc>
+                <a:tc>
+                  <a:txBody>
+                    <a:bodyPr/>
+                    <a:lstStyle/>
+                    <a:p>
+                      <a:pPr>
+                        <a:defRPr sz="1000" b="1"/>
+                      </a:pPr>
+                      <a:r>
+                        <a:t>F</a:t>
+                      </a:r>
+                    </a:p>
+                  </a:txBody>
+                  <a:tcPr marT="18288" marB="18288"/>
+                </a:tc>
+                <a:tc>
+                  <a:txBody>
+                    <a:bodyPr/>
+                    <a:lstStyle/>
+                    <a:p>
+                      <a:pPr>
+                        <a:defRPr sz="1000" b="1"/>
+                      </a:pPr>
+                    </a:p>
+                  </a:txBody>
+                  <a:tcPr marT="18288" marB="18288"/>
+                </a:tc>
+              </a:tr>
+              <a:tr h="228600">
+                <a:tc>
+                  <a:txBody>
+                    <a:bodyPr/>
+                    <a:lstStyle/>
+                    <a:p>
+                      <a:pPr>
+                        <a:defRPr sz="1000" b="0"/>
                       </a:pPr>
                       <a:r>
                         <a:t>Warehouse &amp; Logistics</a:t>
                       </a:r>
                     </a:p>
                   </a:txBody>
-                  <a:tcPr/>
-                </a:tc>
-                <a:tc>
-                  <a:txBody>
-                    <a:bodyPr/>
-                    <a:lstStyle/>
-                    <a:p>
-                      <a:pPr>
-                        <a:defRPr sz="1100" b="0"/>
+                  <a:tcPr marT="18288" marB="18288"/>
+                </a:tc>
+                <a:tc>
+                  <a:txBody>
+                    <a:bodyPr/>
+                    <a:lstStyle/>
+                    <a:p>
+                      <a:pPr>
+                        <a:defRPr sz="1000" b="0"/>
                       </a:pPr>
                       <a:r>
                         <a:t>1,661</a:t>
                       </a:r>
                     </a:p>
                   </a:txBody>
-                  <a:tcPr/>
-                </a:tc>
-                <a:tc>
-                  <a:txBody>
-                    <a:bodyPr/>
-                    <a:lstStyle/>
-                    <a:p>
-                      <a:pPr>
-                        <a:defRPr sz="1100" b="0"/>
+                  <a:tcPr marT="18288" marB="18288"/>
+                </a:tc>
+                <a:tc>
+                  <a:txBody>
+                    <a:bodyPr/>
+                    <a:lstStyle/>
+                    <a:p>
+                      <a:pPr>
+                        <a:defRPr sz="1000" b="0"/>
                       </a:pPr>
                       <a:r>
                         <a:t>1,663</a:t>
                       </a:r>
                     </a:p>
                   </a:txBody>
-                  <a:tcPr/>
-                </a:tc>
-                <a:tc>
-                  <a:txBody>
-                    <a:bodyPr/>
-                    <a:lstStyle/>
-                    <a:p>
-                      <a:pPr>
-                        <a:defRPr sz="1100" b="0"/>
+                  <a:tcPr marT="18288" marB="18288"/>
+                </a:tc>
+                <a:tc>
+                  <a:txBody>
+                    <a:bodyPr/>
+                    <a:lstStyle/>
+                    <a:p>
+                      <a:pPr>
+                        <a:defRPr sz="1000" b="0"/>
                       </a:pPr>
                       <a:r>
                         <a:t>-2.0</a:t>
                       </a:r>
                     </a:p>
                   </a:txBody>
-                  <a:tcPr/>
-                </a:tc>
-                <a:tc>
-                  <a:txBody>
-                    <a:bodyPr/>
-                    <a:lstStyle/>
-                    <a:p>
-                      <a:pPr>
-                        <a:defRPr sz="1100" b="0"/>
+                  <a:tcPr marT="18288" marB="18288"/>
+                </a:tc>
+                <a:tc>
+                  <a:txBody>
+                    <a:bodyPr/>
+                    <a:lstStyle/>
+                    <a:p>
+                      <a:pPr>
+                        <a:defRPr sz="1000" b="0"/>
                       </a:pPr>
                       <a:r>
                         <a:t>-0.1%</a:t>
                       </a:r>
                     </a:p>
                   </a:txBody>
-                  <a:tcPr/>
-                </a:tc>
-                <a:tc>
-                  <a:txBody>
-                    <a:bodyPr/>
-                    <a:lstStyle/>
-                    <a:p>
-                      <a:pPr>
-                        <a:defRPr sz="1100" b="0"/>
-                      </a:pPr>
-                    </a:p>
-                  </a:txBody>
-                  <a:tcPr/>
+                  <a:tcPr marT="18288" marB="18288"/>
+                </a:tc>
+                <a:tc>
+                  <a:txBody>
+                    <a:bodyPr/>
+                    <a:lstStyle/>
+                    <a:p>
+                      <a:pPr>
+                        <a:defRPr sz="1000" b="0"/>
+                      </a:pPr>
+                      <a:r>
+                        <a:t>F</a:t>
+                      </a:r>
+                    </a:p>
+                  </a:txBody>
+                  <a:tcPr marT="18288" marB="18288"/>
+                </a:tc>
+                <a:tc>
+                  <a:txBody>
+                    <a:bodyPr/>
+                    <a:lstStyle/>
+                    <a:p>
+                      <a:pPr>
+                        <a:defRPr sz="1000" b="0"/>
+                      </a:pPr>
+                    </a:p>
+                  </a:txBody>
+                  <a:tcPr marT="18288" marB="18288"/>
                 </a:tc>
               </a:tr>
-              <a:tr h="274320">
-                <a:tc>
-                  <a:txBody>
-                    <a:bodyPr/>
-                    <a:lstStyle/>
-                    <a:p>
-                      <a:pPr>
-                        <a:defRPr sz="1100" b="0"/>
+              <a:tr h="228600">
+                <a:tc>
+                  <a:txBody>
+                    <a:bodyPr/>
+                    <a:lstStyle/>
+                    <a:p>
+                      <a:pPr>
+                        <a:defRPr sz="1000" b="0"/>
                       </a:pPr>
                       <a:r>
                         <a:t>Sales &amp; Account Management</a:t>
                       </a:r>
                     </a:p>
                   </a:txBody>
-                  <a:tcPr/>
-                </a:tc>
-                <a:tc>
-                  <a:txBody>
-                    <a:bodyPr/>
-                    <a:lstStyle/>
-                    <a:p>
-                      <a:pPr>
-                        <a:defRPr sz="1100" b="0"/>
+                  <a:tcPr marT="18288" marB="18288"/>
+                </a:tc>
+                <a:tc>
+                  <a:txBody>
+                    <a:bodyPr/>
+                    <a:lstStyle/>
+                    <a:p>
+                      <a:pPr>
+                        <a:defRPr sz="1000" b="0"/>
                       </a:pPr>
                       <a:r>
                         <a:t>1,257</a:t>
                       </a:r>
                     </a:p>
                   </a:txBody>
-                  <a:tcPr/>
-                </a:tc>
-                <a:tc>
-                  <a:txBody>
-                    <a:bodyPr/>
-                    <a:lstStyle/>
-                    <a:p>
-                      <a:pPr>
-                        <a:defRPr sz="1100" b="0"/>
+                  <a:tcPr marT="18288" marB="18288"/>
+                </a:tc>
+                <a:tc>
+                  <a:txBody>
+                    <a:bodyPr/>
+                    <a:lstStyle/>
+                    <a:p>
+                      <a:pPr>
+                        <a:defRPr sz="1000" b="0"/>
                       </a:pPr>
                       <a:r>
                         <a:t>1,230</a:t>
                       </a:r>
                     </a:p>
                   </a:txBody>
-                  <a:tcPr/>
-                </a:tc>
-                <a:tc>
-                  <a:txBody>
-                    <a:bodyPr/>
-                    <a:lstStyle/>
-                    <a:p>
-                      <a:pPr>
-                        <a:defRPr sz="1100" b="0"/>
+                  <a:tcPr marT="18288" marB="18288"/>
+                </a:tc>
+                <a:tc>
+                  <a:txBody>
+                    <a:bodyPr/>
+                    <a:lstStyle/>
+                    <a:p>
+                      <a:pPr>
+                        <a:defRPr sz="1000" b="0"/>
                       </a:pPr>
                       <a:r>
                         <a:t>+27.0</a:t>
                       </a:r>
                     </a:p>
                   </a:txBody>
-                  <a:tcPr/>
-                </a:tc>
-                <a:tc>
-                  <a:txBody>
-                    <a:bodyPr/>
-                    <a:lstStyle/>
-                    <a:p>
-                      <a:pPr>
-                        <a:defRPr sz="1100" b="0"/>
+                  <a:tcPr marT="18288" marB="18288"/>
+                </a:tc>
+                <a:tc>
+                  <a:txBody>
+                    <a:bodyPr/>
+                    <a:lstStyle/>
+                    <a:p>
+                      <a:pPr>
+                        <a:defRPr sz="1000" b="0"/>
                       </a:pPr>
                       <a:r>
                         <a:t>+2.2%</a:t>
                       </a:r>
                     </a:p>
                   </a:txBody>
-                  <a:tcPr/>
-                </a:tc>
-                <a:tc>
-                  <a:txBody>
-                    <a:bodyPr/>
-                    <a:lstStyle/>
-                    <a:p>
-                      <a:pPr>
-                        <a:defRPr sz="1100" b="0"/>
-                      </a:pPr>
-                    </a:p>
-                  </a:txBody>
-                  <a:tcPr/>
+                  <a:tcPr marT="18288" marB="18288"/>
+                </a:tc>
+                <a:tc>
+                  <a:txBody>
+                    <a:bodyPr/>
+                    <a:lstStyle/>
+                    <a:p>
+                      <a:pPr>
+                        <a:defRPr sz="1000" b="0"/>
+                      </a:pPr>
+                      <a:r>
+                        <a:t>A</a:t>
+                      </a:r>
+                    </a:p>
+                  </a:txBody>
+                  <a:tcPr marT="18288" marB="18288"/>
+                </a:tc>
+                <a:tc>
+                  <a:txBody>
+                    <a:bodyPr/>
+                    <a:lstStyle/>
+                    <a:p>
+                      <a:pPr>
+                        <a:defRPr sz="1000" b="0"/>
+                      </a:pPr>
+                    </a:p>
+                  </a:txBody>
+                  <a:tcPr marT="18288" marB="18288"/>
                 </a:tc>
               </a:tr>
-              <a:tr h="274320">
-                <a:tc>
-                  <a:txBody>
-                    <a:bodyPr/>
-                    <a:lstStyle/>
-                    <a:p>
-                      <a:pPr>
-                        <a:defRPr sz="1100" b="0"/>
+              <a:tr h="228600">
+                <a:tc>
+                  <a:txBody>
+                    <a:bodyPr/>
+                    <a:lstStyle/>
+                    <a:p>
+                      <a:pPr>
+                        <a:defRPr sz="1000" b="0"/>
                       </a:pPr>
                       <a:r>
                         <a:t>Procurement &amp; Merchandising</a:t>
                       </a:r>
                     </a:p>
                   </a:txBody>
-                  <a:tcPr/>
-                </a:tc>
-                <a:tc>
-                  <a:txBody>
-                    <a:bodyPr/>
-                    <a:lstStyle/>
-                    <a:p>
-                      <a:pPr>
-                        <a:defRPr sz="1100" b="0"/>
+                  <a:tcPr marT="18288" marB="18288"/>
+                </a:tc>
+                <a:tc>
+                  <a:txBody>
+                    <a:bodyPr/>
+                    <a:lstStyle/>
+                    <a:p>
+                      <a:pPr>
+                        <a:defRPr sz="1000" b="0"/>
                       </a:pPr>
                       <a:r>
                         <a:t>597</a:t>
                       </a:r>
                     </a:p>
                   </a:txBody>
-                  <a:tcPr/>
-                </a:tc>
-                <a:tc>
-                  <a:txBody>
-                    <a:bodyPr/>
-                    <a:lstStyle/>
-                    <a:p>
-                      <a:pPr>
-                        <a:defRPr sz="1100" b="0"/>
+                  <a:tcPr marT="18288" marB="18288"/>
+                </a:tc>
+                <a:tc>
+                  <a:txBody>
+                    <a:bodyPr/>
+                    <a:lstStyle/>
+                    <a:p>
+                      <a:pPr>
+                        <a:defRPr sz="1000" b="0"/>
                       </a:pPr>
                       <a:r>
                         <a:t>586</a:t>
                       </a:r>
                     </a:p>
                   </a:txBody>
-                  <a:tcPr/>
-                </a:tc>
-                <a:tc>
-                  <a:txBody>
-                    <a:bodyPr/>
-                    <a:lstStyle/>
-                    <a:p>
-                      <a:pPr>
-                        <a:defRPr sz="1100" b="0"/>
+                  <a:tcPr marT="18288" marB="18288"/>
+                </a:tc>
+                <a:tc>
+                  <a:txBody>
+                    <a:bodyPr/>
+                    <a:lstStyle/>
+                    <a:p>
+                      <a:pPr>
+                        <a:defRPr sz="1000" b="0"/>
                       </a:pPr>
                       <a:r>
                         <a:t>+11.0</a:t>
                       </a:r>
                     </a:p>
                   </a:txBody>
-                  <a:tcPr/>
-                </a:tc>
-                <a:tc>
-                  <a:txBody>
-                    <a:bodyPr/>
-                    <a:lstStyle/>
-                    <a:p>
-                      <a:pPr>
-                        <a:defRPr sz="1100" b="0"/>
+                  <a:tcPr marT="18288" marB="18288"/>
+                </a:tc>
+                <a:tc>
+                  <a:txBody>
+                    <a:bodyPr/>
+                    <a:lstStyle/>
+                    <a:p>
+                      <a:pPr>
+                        <a:defRPr sz="1000" b="0"/>
                       </a:pPr>
                       <a:r>
                         <a:t>+1.9%</a:t>
                       </a:r>
                     </a:p>
                   </a:txBody>
-                  <a:tcPr/>
-                </a:tc>
-                <a:tc>
-                  <a:txBody>
-                    <a:bodyPr/>
-                    <a:lstStyle/>
-                    <a:p>
-                      <a:pPr>
-                        <a:defRPr sz="1100" b="0"/>
-                      </a:pPr>
-                    </a:p>
-                  </a:txBody>
-                  <a:tcPr/>
+                  <a:tcPr marT="18288" marB="18288"/>
+                </a:tc>
+                <a:tc>
+                  <a:txBody>
+                    <a:bodyPr/>
+                    <a:lstStyle/>
+                    <a:p>
+                      <a:pPr>
+                        <a:defRPr sz="1000" b="0"/>
+                      </a:pPr>
+                      <a:r>
+                        <a:t>A</a:t>
+                      </a:r>
+                    </a:p>
+                  </a:txBody>
+                  <a:tcPr marT="18288" marB="18288"/>
+                </a:tc>
+                <a:tc>
+                  <a:txBody>
+                    <a:bodyPr/>
+                    <a:lstStyle/>
+                    <a:p>
+                      <a:pPr>
+                        <a:defRPr sz="1000" b="0"/>
+                      </a:pPr>
+                    </a:p>
+                  </a:txBody>
+                  <a:tcPr marT="18288" marB="18288"/>
                 </a:tc>
               </a:tr>
-              <a:tr h="274320">
-                <a:tc>
-                  <a:txBody>
-                    <a:bodyPr/>
-                    <a:lstStyle/>
-                    <a:p>
-                      <a:pPr>
-                        <a:defRPr sz="1100" b="0"/>
+              <a:tr h="228600">
+                <a:tc>
+                  <a:txBody>
+                    <a:bodyPr/>
+                    <a:lstStyle/>
+                    <a:p>
+                      <a:pPr>
+                        <a:defRPr sz="1000" b="0"/>
                       </a:pPr>
                       <a:r>
                         <a:t>IT &amp; Digital</a:t>
                       </a:r>
                     </a:p>
                   </a:txBody>
-                  <a:tcPr/>
-                </a:tc>
-                <a:tc>
-                  <a:txBody>
-                    <a:bodyPr/>
-                    <a:lstStyle/>
-                    <a:p>
-                      <a:pPr>
-                        <a:defRPr sz="1100" b="0"/>
+                  <a:tcPr marT="18288" marB="18288"/>
+                </a:tc>
+                <a:tc>
+                  <a:txBody>
+                    <a:bodyPr/>
+                    <a:lstStyle/>
+                    <a:p>
+                      <a:pPr>
+                        <a:defRPr sz="1000" b="0"/>
                       </a:pPr>
                       <a:r>
                         <a:t>521</a:t>
                       </a:r>
                     </a:p>
                   </a:txBody>
-                  <a:tcPr/>
-                </a:tc>
-                <a:tc>
-                  <a:txBody>
-                    <a:bodyPr/>
-                    <a:lstStyle/>
-                    <a:p>
-                      <a:pPr>
-                        <a:defRPr sz="1100" b="0"/>
+                  <a:tcPr marT="18288" marB="18288"/>
+                </a:tc>
+                <a:tc>
+                  <a:txBody>
+                    <a:bodyPr/>
+                    <a:lstStyle/>
+                    <a:p>
+                      <a:pPr>
+                        <a:defRPr sz="1000" b="0"/>
                       </a:pPr>
                       <a:r>
                         <a:t>519</a:t>
                       </a:r>
                     </a:p>
                   </a:txBody>
-                  <a:tcPr/>
-                </a:tc>
-                <a:tc>
-                  <a:txBody>
-                    <a:bodyPr/>
-                    <a:lstStyle/>
-                    <a:p>
-                      <a:pPr>
-                        <a:defRPr sz="1100" b="0"/>
+                  <a:tcPr marT="18288" marB="18288"/>
+                </a:tc>
+                <a:tc>
+                  <a:txBody>
+                    <a:bodyPr/>
+                    <a:lstStyle/>
+                    <a:p>
+                      <a:pPr>
+                        <a:defRPr sz="1000" b="0"/>
                       </a:pPr>
                       <a:r>
                         <a:t>+2.0</a:t>
                       </a:r>
                     </a:p>
                   </a:txBody>
-                  <a:tcPr/>
-                </a:tc>
-                <a:tc>
-                  <a:txBody>
-                    <a:bodyPr/>
-                    <a:lstStyle/>
-                    <a:p>
-                      <a:pPr>
-                        <a:defRPr sz="1100" b="0"/>
+                  <a:tcPr marT="18288" marB="18288"/>
+                </a:tc>
+                <a:tc>
+                  <a:txBody>
+                    <a:bodyPr/>
+                    <a:lstStyle/>
+                    <a:p>
+                      <a:pPr>
+                        <a:defRPr sz="1000" b="0"/>
                       </a:pPr>
                       <a:r>
                         <a:t>+0.4%</a:t>
                       </a:r>
                     </a:p>
                   </a:txBody>
-                  <a:tcPr/>
-                </a:tc>
-                <a:tc>
-                  <a:txBody>
-                    <a:bodyPr/>
-                    <a:lstStyle/>
-                    <a:p>
-                      <a:pPr>
-                        <a:defRPr sz="1100" b="0"/>
-                      </a:pPr>
-                    </a:p>
-                  </a:txBody>
-                  <a:tcPr/>
+                  <a:tcPr marT="18288" marB="18288"/>
+                </a:tc>
+                <a:tc>
+                  <a:txBody>
+                    <a:bodyPr/>
+                    <a:lstStyle/>
+                    <a:p>
+                      <a:pPr>
+                        <a:defRPr sz="1000" b="0"/>
+                      </a:pPr>
+                      <a:r>
+                        <a:t>A</a:t>
+                      </a:r>
+                    </a:p>
+                  </a:txBody>
+                  <a:tcPr marT="18288" marB="18288"/>
+                </a:tc>
+                <a:tc>
+                  <a:txBody>
+                    <a:bodyPr/>
+                    <a:lstStyle/>
+                    <a:p>
+                      <a:pPr>
+                        <a:defRPr sz="1000" b="0"/>
+                      </a:pPr>
+                    </a:p>
+                  </a:txBody>
+                  <a:tcPr marT="18288" marB="18288"/>
                 </a:tc>
               </a:tr>
-              <a:tr h="274320">
-                <a:tc>
-                  <a:txBody>
-                    <a:bodyPr/>
-                    <a:lstStyle/>
-                    <a:p>
-                      <a:pPr>
-                        <a:defRPr sz="1100" b="0"/>
+              <a:tr h="228600">
+                <a:tc>
+                  <a:txBody>
+                    <a:bodyPr/>
+                    <a:lstStyle/>
+                    <a:p>
+                      <a:pPr>
+                        <a:defRPr sz="1000" b="0"/>
                       </a:pPr>
                       <a:r>
                         <a:t>General &amp; Administrative</a:t>
                       </a:r>
                     </a:p>
                   </a:txBody>
-                  <a:tcPr/>
-                </a:tc>
-                <a:tc>
-                  <a:txBody>
-                    <a:bodyPr/>
-                    <a:lstStyle/>
-                    <a:p>
-                      <a:pPr>
-                        <a:defRPr sz="1100" b="0"/>
+                  <a:tcPr marT="18288" marB="18288"/>
+                </a:tc>
+                <a:tc>
+                  <a:txBody>
+                    <a:bodyPr/>
+                    <a:lstStyle/>
+                    <a:p>
+                      <a:pPr>
+                        <a:defRPr sz="1000" b="0"/>
                       </a:pPr>
                       <a:r>
                         <a:t>796</a:t>
                       </a:r>
                     </a:p>
                   </a:txBody>
-                  <a:tcPr/>
-                </a:tc>
-                <a:tc>
-                  <a:txBody>
-                    <a:bodyPr/>
-                    <a:lstStyle/>
-                    <a:p>
-                      <a:pPr>
-                        <a:defRPr sz="1100" b="0"/>
+                  <a:tcPr marT="18288" marB="18288"/>
+                </a:tc>
+                <a:tc>
+                  <a:txBody>
+                    <a:bodyPr/>
+                    <a:lstStyle/>
+                    <a:p>
+                      <a:pPr>
+                        <a:defRPr sz="1000" b="0"/>
                       </a:pPr>
                       <a:r>
                         <a:t>807</a:t>
                       </a:r>
                     </a:p>
                   </a:txBody>
-                  <a:tcPr/>
-                </a:tc>
-                <a:tc>
-                  <a:txBody>
-                    <a:bodyPr/>
-                    <a:lstStyle/>
-                    <a:p>
-                      <a:pPr>
-                        <a:defRPr sz="1100" b="0"/>
+                  <a:tcPr marT="18288" marB="18288"/>
+                </a:tc>
+                <a:tc>
+                  <a:txBody>
+                    <a:bodyPr/>
+                    <a:lstStyle/>
+                    <a:p>
+                      <a:pPr>
+                        <a:defRPr sz="1000" b="0"/>
                       </a:pPr>
                       <a:r>
                         <a:t>-11.0</a:t>
                       </a:r>
                     </a:p>
                   </a:txBody>
-                  <a:tcPr/>
-                </a:tc>
-                <a:tc>
-                  <a:txBody>
-                    <a:bodyPr/>
-                    <a:lstStyle/>
-                    <a:p>
-                      <a:pPr>
-                        <a:defRPr sz="1100" b="0"/>
+                  <a:tcPr marT="18288" marB="18288"/>
+                </a:tc>
+                <a:tc>
+                  <a:txBody>
+                    <a:bodyPr/>
+                    <a:lstStyle/>
+                    <a:p>
+                      <a:pPr>
+                        <a:defRPr sz="1000" b="0"/>
                       </a:pPr>
                       <a:r>
                         <a:t>-1.4%</a:t>
                       </a:r>
                     </a:p>
                   </a:txBody>
-                  <a:tcPr/>
-                </a:tc>
-                <a:tc>
-                  <a:txBody>
-                    <a:bodyPr/>
-                    <a:lstStyle/>
-                    <a:p>
-                      <a:pPr>
-                        <a:defRPr sz="1100" b="0"/>
-                      </a:pPr>
-                    </a:p>
-                  </a:txBody>
-                  <a:tcPr/>
+                  <a:tcPr marT="18288" marB="18288"/>
+                </a:tc>
+                <a:tc>
+                  <a:txBody>
+                    <a:bodyPr/>
+                    <a:lstStyle/>
+                    <a:p>
+                      <a:pPr>
+                        <a:defRPr sz="1000" b="0"/>
+                      </a:pPr>
+                      <a:r>
+                        <a:t>F</a:t>
+                      </a:r>
+                    </a:p>
+                  </a:txBody>
+                  <a:tcPr marT="18288" marB="18288"/>
+                </a:tc>
+                <a:tc>
+                  <a:txBody>
+                    <a:bodyPr/>
+                    <a:lstStyle/>
+                    <a:p>
+                      <a:pPr>
+                        <a:defRPr sz="1000" b="0"/>
+                      </a:pPr>
+                    </a:p>
+                  </a:txBody>
+                  <a:tcPr marT="18288" marB="18288"/>
                 </a:tc>
               </a:tr>
-              <a:tr h="274320">
-                <a:tc>
-                  <a:txBody>
-                    <a:bodyPr/>
-                    <a:lstStyle/>
-                    <a:p>
-                      <a:pPr>
-                        <a:defRPr sz="1100" b="0"/>
+              <a:tr h="228600">
+                <a:tc>
+                  <a:txBody>
+                    <a:bodyPr/>
+                    <a:lstStyle/>
+                    <a:p>
+                      <a:pPr>
+                        <a:defRPr sz="1000" b="1"/>
+                      </a:pPr>
+                      <a:r>
+                        <a:t>Total operating expenses</a:t>
+                      </a:r>
+                    </a:p>
+                  </a:txBody>
+                  <a:tcPr marT="18288" marB="18288"/>
+                </a:tc>
+                <a:tc>
+                  <a:txBody>
+                    <a:bodyPr/>
+                    <a:lstStyle/>
+                    <a:p>
+                      <a:pPr>
+                        <a:defRPr sz="1000" b="1"/>
+                      </a:pPr>
+                      <a:r>
+                        <a:t>4,832</a:t>
+                      </a:r>
+                    </a:p>
+                  </a:txBody>
+                  <a:tcPr marT="18288" marB="18288"/>
+                </a:tc>
+                <a:tc>
+                  <a:txBody>
+                    <a:bodyPr/>
+                    <a:lstStyle/>
+                    <a:p>
+                      <a:pPr>
+                        <a:defRPr sz="1000" b="1"/>
+                      </a:pPr>
+                      <a:r>
+                        <a:t>4,805</a:t>
+                      </a:r>
+                    </a:p>
+                  </a:txBody>
+                  <a:tcPr marT="18288" marB="18288"/>
+                </a:tc>
+                <a:tc>
+                  <a:txBody>
+                    <a:bodyPr/>
+                    <a:lstStyle/>
+                    <a:p>
+                      <a:pPr>
+                        <a:defRPr sz="1000" b="1"/>
+                      </a:pPr>
+                      <a:r>
+                        <a:t>+27.0</a:t>
+                      </a:r>
+                    </a:p>
+                  </a:txBody>
+                  <a:tcPr marT="18288" marB="18288"/>
+                </a:tc>
+                <a:tc>
+                  <a:txBody>
+                    <a:bodyPr/>
+                    <a:lstStyle/>
+                    <a:p>
+                      <a:pPr>
+                        <a:defRPr sz="1000" b="1"/>
+                      </a:pPr>
+                    </a:p>
+                  </a:txBody>
+                  <a:tcPr marT="18288" marB="18288"/>
+                </a:tc>
+                <a:tc>
+                  <a:txBody>
+                    <a:bodyPr/>
+                    <a:lstStyle/>
+                    <a:p>
+                      <a:pPr>
+                        <a:defRPr sz="1000" b="1"/>
+                      </a:pPr>
+                      <a:r>
+                        <a:t>A</a:t>
+                      </a:r>
+                    </a:p>
+                  </a:txBody>
+                  <a:tcPr marT="18288" marB="18288"/>
+                </a:tc>
+                <a:tc>
+                  <a:txBody>
+                    <a:bodyPr/>
+                    <a:lstStyle/>
+                    <a:p>
+                      <a:pPr>
+                        <a:defRPr sz="1000" b="1"/>
+                      </a:pPr>
+                    </a:p>
+                  </a:txBody>
+                  <a:tcPr marT="18288" marB="18288"/>
+                </a:tc>
+              </a:tr>
+              <a:tr h="228600">
+                <a:tc>
+                  <a:txBody>
+                    <a:bodyPr/>
+                    <a:lstStyle/>
+                    <a:p>
+                      <a:pPr>
+                        <a:defRPr sz="1000" b="1"/>
+                      </a:pPr>
+                      <a:r>
+                        <a:t>EBITDA</a:t>
+                      </a:r>
+                    </a:p>
+                  </a:txBody>
+                  <a:tcPr marT="18288" marB="18288"/>
+                </a:tc>
+                <a:tc>
+                  <a:txBody>
+                    <a:bodyPr/>
+                    <a:lstStyle/>
+                    <a:p>
+                      <a:pPr>
+                        <a:defRPr sz="1000" b="1"/>
+                      </a:pPr>
+                      <a:r>
+                        <a:t>388</a:t>
+                      </a:r>
+                    </a:p>
+                  </a:txBody>
+                  <a:tcPr marT="18288" marB="18288"/>
+                </a:tc>
+                <a:tc>
+                  <a:txBody>
+                    <a:bodyPr/>
+                    <a:lstStyle/>
+                    <a:p>
+                      <a:pPr>
+                        <a:defRPr sz="1000" b="1"/>
+                      </a:pPr>
+                      <a:r>
+                        <a:t>349</a:t>
+                      </a:r>
+                    </a:p>
+                  </a:txBody>
+                  <a:tcPr marT="18288" marB="18288"/>
+                </a:tc>
+                <a:tc>
+                  <a:txBody>
+                    <a:bodyPr/>
+                    <a:lstStyle/>
+                    <a:p>
+                      <a:pPr>
+                        <a:defRPr sz="1000" b="1"/>
+                      </a:pPr>
+                      <a:r>
+                        <a:t>+39.0</a:t>
+                      </a:r>
+                    </a:p>
+                  </a:txBody>
+                  <a:tcPr marT="18288" marB="18288"/>
+                </a:tc>
+                <a:tc>
+                  <a:txBody>
+                    <a:bodyPr/>
+                    <a:lstStyle/>
+                    <a:p>
+                      <a:pPr>
+                        <a:defRPr sz="1000" b="1"/>
+                      </a:pPr>
+                    </a:p>
+                  </a:txBody>
+                  <a:tcPr marT="18288" marB="18288"/>
+                </a:tc>
+                <a:tc>
+                  <a:txBody>
+                    <a:bodyPr/>
+                    <a:lstStyle/>
+                    <a:p>
+                      <a:pPr>
+                        <a:defRPr sz="1000" b="1"/>
+                      </a:pPr>
+                      <a:r>
+                        <a:t>F</a:t>
+                      </a:r>
+                    </a:p>
+                  </a:txBody>
+                  <a:tcPr marT="18288" marB="18288"/>
+                </a:tc>
+                <a:tc>
+                  <a:txBody>
+                    <a:bodyPr/>
+                    <a:lstStyle/>
+                    <a:p>
+                      <a:pPr>
+                        <a:defRPr sz="1000" b="1"/>
+                      </a:pPr>
+                    </a:p>
+                  </a:txBody>
+                  <a:tcPr marT="18288" marB="18288"/>
+                </a:tc>
+              </a:tr>
+              <a:tr h="228600">
+                <a:tc>
+                  <a:txBody>
+                    <a:bodyPr/>
+                    <a:lstStyle/>
+                    <a:p>
+                      <a:pPr>
+                        <a:defRPr sz="1000" b="0"/>
                       </a:pPr>
                       <a:r>
                         <a:t>Depreciation &amp; amortisation</a:t>
                       </a:r>
                     </a:p>
                   </a:txBody>
-                  <a:tcPr/>
-                </a:tc>
-                <a:tc>
-                  <a:txBody>
-                    <a:bodyPr/>
-                    <a:lstStyle/>
-                    <a:p>
-                      <a:pPr>
-                        <a:defRPr sz="1100" b="0"/>
+                  <a:tcPr marT="18288" marB="18288"/>
+                </a:tc>
+                <a:tc>
+                  <a:txBody>
+                    <a:bodyPr/>
+                    <a:lstStyle/>
+                    <a:p>
+                      <a:pPr>
+                        <a:defRPr sz="1000" b="0"/>
                       </a:pPr>
                       <a:r>
                         <a:t>400</a:t>
                       </a:r>
                     </a:p>
                   </a:txBody>
-                  <a:tcPr/>
-                </a:tc>
-                <a:tc>
-                  <a:txBody>
-                    <a:bodyPr/>
-                    <a:lstStyle/>
-                    <a:p>
-                      <a:pPr>
-                        <a:defRPr sz="1100" b="0"/>
+                  <a:tcPr marT="18288" marB="18288"/>
+                </a:tc>
+                <a:tc>
+                  <a:txBody>
+                    <a:bodyPr/>
+                    <a:lstStyle/>
+                    <a:p>
+                      <a:pPr>
+                        <a:defRPr sz="1000" b="0"/>
                       </a:pPr>
                       <a:r>
                         <a:t>400</a:t>
                       </a:r>
                     </a:p>
                   </a:txBody>
-                  <a:tcPr/>
-                </a:tc>
-                <a:tc>
-                  <a:txBody>
-                    <a:bodyPr/>
-                    <a:lstStyle/>
-                    <a:p>
-                      <a:pPr>
-                        <a:defRPr sz="1100" b="0"/>
+                  <a:tcPr marT="18288" marB="18288"/>
+                </a:tc>
+                <a:tc>
+                  <a:txBody>
+                    <a:bodyPr/>
+                    <a:lstStyle/>
+                    <a:p>
+                      <a:pPr>
+                        <a:defRPr sz="1000" b="0"/>
                       </a:pPr>
                       <a:r>
                         <a:t>+0.0</a:t>
                       </a:r>
                     </a:p>
                   </a:txBody>
-                  <a:tcPr/>
-                </a:tc>
-                <a:tc>
-                  <a:txBody>
-                    <a:bodyPr/>
-                    <a:lstStyle/>
-                    <a:p>
-                      <a:pPr>
-                        <a:defRPr sz="1100" b="0"/>
+                  <a:tcPr marT="18288" marB="18288"/>
+                </a:tc>
+                <a:tc>
+                  <a:txBody>
+                    <a:bodyPr/>
+                    <a:lstStyle/>
+                    <a:p>
+                      <a:pPr>
+                        <a:defRPr sz="1000" b="0"/>
                       </a:pPr>
                       <a:r>
                         <a:t>+0.0%</a:t>
                       </a:r>
                     </a:p>
                   </a:txBody>
-                  <a:tcPr/>
-                </a:tc>
-                <a:tc>
-                  <a:txBody>
-                    <a:bodyPr/>
-                    <a:lstStyle/>
-                    <a:p>
-                      <a:pPr>
-                        <a:defRPr sz="1100" b="0"/>
-                      </a:pPr>
-                    </a:p>
-                  </a:txBody>
-                  <a:tcPr/>
+                  <a:tcPr marT="18288" marB="18288"/>
+                </a:tc>
+                <a:tc>
+                  <a:txBody>
+                    <a:bodyPr/>
+                    <a:lstStyle/>
+                    <a:p>
+                      <a:pPr>
+                        <a:defRPr sz="1000" b="0"/>
+                      </a:pPr>
+                    </a:p>
+                  </a:txBody>
+                  <a:tcPr marT="18288" marB="18288"/>
+                </a:tc>
+                <a:tc>
+                  <a:txBody>
+                    <a:bodyPr/>
+                    <a:lstStyle/>
+                    <a:p>
+                      <a:pPr>
+                        <a:defRPr sz="1000" b="0"/>
+                      </a:pPr>
+                    </a:p>
+                  </a:txBody>
+                  <a:tcPr marT="18288" marB="18288"/>
                 </a:tc>
               </a:tr>
-              <a:tr h="274320">
-                <a:tc>
-                  <a:txBody>
-                    <a:bodyPr/>
-                    <a:lstStyle/>
-                    <a:p>
-                      <a:pPr>
-                        <a:defRPr sz="1100" b="0"/>
+              <a:tr h="228600">
+                <a:tc>
+                  <a:txBody>
+                    <a:bodyPr/>
+                    <a:lstStyle/>
+                    <a:p>
+                      <a:pPr>
+                        <a:defRPr sz="1000" b="0"/>
                       </a:pPr>
                       <a:r>
                         <a:t>Interest expense, net</a:t>
                       </a:r>
                     </a:p>
                   </a:txBody>
-                  <a:tcPr/>
-                </a:tc>
-                <a:tc>
-                  <a:txBody>
-                    <a:bodyPr/>
-                    <a:lstStyle/>
-                    <a:p>
-                      <a:pPr>
-                        <a:defRPr sz="1100" b="0"/>
+                  <a:tcPr marT="18288" marB="18288"/>
+                </a:tc>
+                <a:tc>
+                  <a:txBody>
+                    <a:bodyPr/>
+                    <a:lstStyle/>
+                    <a:p>
+                      <a:pPr>
+                        <a:defRPr sz="1000" b="0"/>
                       </a:pPr>
                       <a:r>
                         <a:t>132</a:t>
                       </a:r>
                     </a:p>
                   </a:txBody>
-                  <a:tcPr/>
-                </a:tc>
-                <a:tc>
-                  <a:txBody>
-                    <a:bodyPr/>
-                    <a:lstStyle/>
-                    <a:p>
-                      <a:pPr>
-                        <a:defRPr sz="1100" b="0"/>
+                  <a:tcPr marT="18288" marB="18288"/>
+                </a:tc>
+                <a:tc>
+                  <a:txBody>
+                    <a:bodyPr/>
+                    <a:lstStyle/>
+                    <a:p>
+                      <a:pPr>
+                        <a:defRPr sz="1000" b="0"/>
                       </a:pPr>
                       <a:r>
                         <a:t>132</a:t>
                       </a:r>
                     </a:p>
                   </a:txBody>
-                  <a:tcPr/>
-                </a:tc>
-                <a:tc>
-                  <a:txBody>
-                    <a:bodyPr/>
-                    <a:lstStyle/>
-                    <a:p>
-                      <a:pPr>
-                        <a:defRPr sz="1100" b="0"/>
+                  <a:tcPr marT="18288" marB="18288"/>
+                </a:tc>
+                <a:tc>
+                  <a:txBody>
+                    <a:bodyPr/>
+                    <a:lstStyle/>
+                    <a:p>
+                      <a:pPr>
+                        <a:defRPr sz="1000" b="0"/>
                       </a:pPr>
                       <a:r>
                         <a:t>+0.0</a:t>
                       </a:r>
                     </a:p>
                   </a:txBody>
-                  <a:tcPr/>
-                </a:tc>
-                <a:tc>
-                  <a:txBody>
-                    <a:bodyPr/>
-                    <a:lstStyle/>
-                    <a:p>
-                      <a:pPr>
-                        <a:defRPr sz="1100" b="0"/>
+                  <a:tcPr marT="18288" marB="18288"/>
+                </a:tc>
+                <a:tc>
+                  <a:txBody>
+                    <a:bodyPr/>
+                    <a:lstStyle/>
+                    <a:p>
+                      <a:pPr>
+                        <a:defRPr sz="1000" b="0"/>
                       </a:pPr>
                       <a:r>
                         <a:t>+0.0%</a:t>
                       </a:r>
                     </a:p>
                   </a:txBody>
-                  <a:tcPr/>
-                </a:tc>
-                <a:tc>
-                  <a:txBody>
-                    <a:bodyPr/>
-                    <a:lstStyle/>
-                    <a:p>
-                      <a:pPr>
-                        <a:defRPr sz="1100" b="0"/>
-                      </a:pPr>
-                    </a:p>
-                  </a:txBody>
-                  <a:tcPr/>
+                  <a:tcPr marT="18288" marB="18288"/>
+                </a:tc>
+                <a:tc>
+                  <a:txBody>
+                    <a:bodyPr/>
+                    <a:lstStyle/>
+                    <a:p>
+                      <a:pPr>
+                        <a:defRPr sz="1000" b="0"/>
+                      </a:pPr>
+                    </a:p>
+                  </a:txBody>
+                  <a:tcPr marT="18288" marB="18288"/>
+                </a:tc>
+                <a:tc>
+                  <a:txBody>
+                    <a:bodyPr/>
+                    <a:lstStyle/>
+                    <a:p>
+                      <a:pPr>
+                        <a:defRPr sz="1000" b="0"/>
+                      </a:pPr>
+                    </a:p>
+                  </a:txBody>
+                  <a:tcPr marT="18288" marB="18288"/>
                 </a:tc>
               </a:tr>
-              <a:tr h="274320">
-                <a:tc>
-                  <a:txBody>
-                    <a:bodyPr/>
-                    <a:lstStyle/>
-                    <a:p>
-                      <a:pPr>
-                        <a:defRPr sz="1100" b="0"/>
+              <a:tr h="228600">
+                <a:tc>
+                  <a:txBody>
+                    <a:bodyPr/>
+                    <a:lstStyle/>
+                    <a:p>
+                      <a:pPr>
+                        <a:defRPr sz="1000" b="0"/>
                       </a:pPr>
                       <a:r>
                         <a:t>Taxation</a:t>
                       </a:r>
                     </a:p>
                   </a:txBody>
-                  <a:tcPr/>
-                </a:tc>
-                <a:tc>
-                  <a:txBody>
-                    <a:bodyPr/>
-                    <a:lstStyle/>
-                    <a:p>
-                      <a:pPr>
-                        <a:defRPr sz="1100" b="0"/>
+                  <a:tcPr marT="18288" marB="18288"/>
+                </a:tc>
+                <a:tc>
+                  <a:txBody>
+                    <a:bodyPr/>
+                    <a:lstStyle/>
+                    <a:p>
+                      <a:pPr>
+                        <a:defRPr sz="1000" b="0"/>
                       </a:pPr>
                       <a:r>
                         <a:t>-36</a:t>
                       </a:r>
                     </a:p>
                   </a:txBody>
-                  <a:tcPr/>
-                </a:tc>
-                <a:tc>
-                  <a:txBody>
-                    <a:bodyPr/>
-                    <a:lstStyle/>
-                    <a:p>
-                      <a:pPr>
-                        <a:defRPr sz="1100" b="0"/>
+                  <a:tcPr marT="18288" marB="18288"/>
+                </a:tc>
+                <a:tc>
+                  <a:txBody>
+                    <a:bodyPr/>
+                    <a:lstStyle/>
+                    <a:p>
+                      <a:pPr>
+                        <a:defRPr sz="1000" b="0"/>
                       </a:pPr>
                       <a:r>
                         <a:t>0</a:t>
                       </a:r>
                     </a:p>
                   </a:txBody>
-                  <a:tcPr/>
-                </a:tc>
-                <a:tc>
-                  <a:txBody>
-                    <a:bodyPr/>
-                    <a:lstStyle/>
-                    <a:p>
-                      <a:pPr>
-                        <a:defRPr sz="1100" b="0"/>
+                  <a:tcPr marT="18288" marB="18288"/>
+                </a:tc>
+                <a:tc>
+                  <a:txBody>
+                    <a:bodyPr/>
+                    <a:lstStyle/>
+                    <a:p>
+                      <a:pPr>
+                        <a:defRPr sz="1000" b="0"/>
                       </a:pPr>
                       <a:r>
                         <a:t>-36.0</a:t>
                       </a:r>
                     </a:p>
                   </a:txBody>
-                  <a:tcPr/>
-                </a:tc>
-                <a:tc>
-                  <a:txBody>
-                    <a:bodyPr/>
-                    <a:lstStyle/>
-                    <a:p>
-                      <a:pPr>
-                        <a:defRPr sz="1100" b="0"/>
-                      </a:pPr>
-                    </a:p>
-                  </a:txBody>
-                  <a:tcPr/>
-                </a:tc>
-                <a:tc>
-                  <a:txBody>
-                    <a:bodyPr/>
-                    <a:lstStyle/>
-                    <a:p>
-                      <a:pPr>
-                        <a:defRPr sz="1100" b="0"/>
-                      </a:pPr>
-                    </a:p>
-                  </a:txBody>
-                  <a:tcPr/>
+                  <a:tcPr marT="18288" marB="18288"/>
+                </a:tc>
+                <a:tc>
+                  <a:txBody>
+                    <a:bodyPr/>
+                    <a:lstStyle/>
+                    <a:p>
+                      <a:pPr>
+                        <a:defRPr sz="1000" b="0"/>
+                      </a:pPr>
+                    </a:p>
+                  </a:txBody>
+                  <a:tcPr marT="18288" marB="18288"/>
+                </a:tc>
+                <a:tc>
+                  <a:txBody>
+                    <a:bodyPr/>
+                    <a:lstStyle/>
+                    <a:p>
+                      <a:pPr>
+                        <a:defRPr sz="1000" b="0"/>
+                      </a:pPr>
+                      <a:r>
+                        <a:t>F</a:t>
+                      </a:r>
+                    </a:p>
+                  </a:txBody>
+                  <a:tcPr marT="18288" marB="18288"/>
+                </a:tc>
+                <a:tc>
+                  <a:txBody>
+                    <a:bodyPr/>
+                    <a:lstStyle/>
+                    <a:p>
+                      <a:pPr>
+                        <a:defRPr sz="1000" b="0"/>
+                      </a:pPr>
+                    </a:p>
+                  </a:txBody>
+                  <a:tcPr marT="18288" marB="18288"/>
                 </a:tc>
               </a:tr>
-              <a:tr h="274320">
-                <a:tc>
-                  <a:txBody>
-                    <a:bodyPr/>
-                    <a:lstStyle/>
-                    <a:p>
-                      <a:pPr>
-                        <a:defRPr sz="1100" b="1"/>
-                      </a:pPr>
-                      <a:r>
-                        <a:t>TOTAL</a:t>
-                      </a:r>
-                    </a:p>
-                  </a:txBody>
-                  <a:tcPr/>
-                </a:tc>
-                <a:tc>
-                  <a:txBody>
-                    <a:bodyPr/>
-                    <a:lstStyle/>
-                    <a:p>
-                      <a:pPr>
-                        <a:defRPr sz="1100" b="1"/>
-                      </a:pPr>
-                      <a:r>
-                        <a:t>42,234</a:t>
-                      </a:r>
-                    </a:p>
-                  </a:txBody>
-                  <a:tcPr/>
-                </a:tc>
-                <a:tc>
-                  <a:txBody>
-                    <a:bodyPr/>
-                    <a:lstStyle/>
-                    <a:p>
-                      <a:pPr>
-                        <a:defRPr sz="1100" b="1"/>
-                      </a:pPr>
-                      <a:r>
-                        <a:t>41,689</a:t>
-                      </a:r>
-                    </a:p>
-                  </a:txBody>
-                  <a:tcPr/>
-                </a:tc>
-                <a:tc>
-                  <a:txBody>
-                    <a:bodyPr/>
-                    <a:lstStyle/>
-                    <a:p>
-                      <a:pPr>
-                        <a:defRPr sz="1100" b="1"/>
-                      </a:pPr>
-                      <a:r>
-                        <a:t>+545.0</a:t>
-                      </a:r>
-                    </a:p>
-                  </a:txBody>
-                  <a:tcPr/>
-                </a:tc>
-                <a:tc>
-                  <a:txBody>
-                    <a:bodyPr/>
-                    <a:lstStyle/>
-                    <a:p>
-                      <a:pPr>
-                        <a:defRPr sz="1100" b="1"/>
-                      </a:pPr>
-                    </a:p>
-                  </a:txBody>
-                  <a:tcPr/>
-                </a:tc>
-                <a:tc>
-                  <a:txBody>
-                    <a:bodyPr/>
-                    <a:lstStyle/>
-                    <a:p>
-                      <a:pPr>
-                        <a:defRPr sz="1100" b="1"/>
-                      </a:pPr>
-                    </a:p>
-                  </a:txBody>
-                  <a:tcPr/>
+              <a:tr h="228600">
+                <a:tc>
+                  <a:txBody>
+                    <a:bodyPr/>
+                    <a:lstStyle/>
+                    <a:p>
+                      <a:pPr>
+                        <a:defRPr sz="1000" b="1"/>
+                      </a:pPr>
+                      <a:r>
+                        <a:t>Net result</a:t>
+                      </a:r>
+                    </a:p>
+                  </a:txBody>
+                  <a:tcPr marT="18288" marB="18288"/>
+                </a:tc>
+                <a:tc>
+                  <a:txBody>
+                    <a:bodyPr/>
+                    <a:lstStyle/>
+                    <a:p>
+                      <a:pPr>
+                        <a:defRPr sz="1000" b="1"/>
+                      </a:pPr>
+                      <a:r>
+                        <a:t>-108</a:t>
+                      </a:r>
+                    </a:p>
+                  </a:txBody>
+                  <a:tcPr marT="18288" marB="18288"/>
+                </a:tc>
+                <a:tc>
+                  <a:txBody>
+                    <a:bodyPr/>
+                    <a:lstStyle/>
+                    <a:p>
+                      <a:pPr>
+                        <a:defRPr sz="1000" b="1"/>
+                      </a:pPr>
+                      <a:r>
+                        <a:t>-183</a:t>
+                      </a:r>
+                    </a:p>
+                  </a:txBody>
+                  <a:tcPr marT="18288" marB="18288"/>
+                </a:tc>
+                <a:tc>
+                  <a:txBody>
+                    <a:bodyPr/>
+                    <a:lstStyle/>
+                    <a:p>
+                      <a:pPr>
+                        <a:defRPr sz="1000" b="1"/>
+                      </a:pPr>
+                      <a:r>
+                        <a:t>+75.0</a:t>
+                      </a:r>
+                    </a:p>
+                  </a:txBody>
+                  <a:tcPr marT="18288" marB="18288"/>
+                </a:tc>
+                <a:tc>
+                  <a:txBody>
+                    <a:bodyPr/>
+                    <a:lstStyle/>
+                    <a:p>
+                      <a:pPr>
+                        <a:defRPr sz="1000" b="1"/>
+                      </a:pPr>
+                    </a:p>
+                  </a:txBody>
+                  <a:tcPr marT="18288" marB="18288"/>
+                </a:tc>
+                <a:tc>
+                  <a:txBody>
+                    <a:bodyPr/>
+                    <a:lstStyle/>
+                    <a:p>
+                      <a:pPr>
+                        <a:defRPr sz="1000" b="1"/>
+                      </a:pPr>
+                      <a:r>
+                        <a:t>F</a:t>
+                      </a:r>
+                    </a:p>
+                  </a:txBody>
+                  <a:tcPr marT="18288" marB="18288"/>
+                </a:tc>
+                <a:tc>
+                  <a:txBody>
+                    <a:bodyPr/>
+                    <a:lstStyle/>
+                    <a:p>
+                      <a:pPr>
+                        <a:defRPr sz="1000" b="1"/>
+                      </a:pPr>
+                    </a:p>
+                  </a:txBody>
+                  <a:tcPr marT="18288" marB="18288"/>
                 </a:tc>
               </a:tr>
             </a:tbl>
@@ -4839,7 +5448,7 @@
               <a:defRPr sz="1200"/>
             </a:pPr>
             <a:r>
-              <a:t>Bank position: the cashbook balance is £8,911,388.92, agreeing to the bank statement balance of £9,882,613.23 after unpresented payments and uncleared lodgements (Bank Reconciliation - Operating Account - May-26 SIGNED KL.xlsx). Cheque 004182 (Airedale Window Cleaning, £1,850.00) is to be stopped and reissued, as decided by KL.</a:t>
+              <a:t>Facilities &amp; Safety Supplies: revenue 8,343 against budget 8,216, +127.0 favourable. Driver not evidenced in the documents: Commercial Director to comment. (Source: signed Variance Report - May-26, commentary sheet.)</a:t>
             </a:r>
           </a:p>
           <a:p>
@@ -4847,7 +5456,7 @@
               <a:defRPr sz="1200"/>
             </a:pPr>
             <a:r>
-              <a:t>Facilities &amp; Safety Supplies: actual 8,343 against budget 8,216, +127.0 (£'000). Driver not evidenced in the documents: Commercial Director to comment (Variance Report - May-26 SIGNED KL.xlsx).</a:t>
+              <a:t>Industrial Consumables &amp; Packaging: revenue 8,464 against budget 8,361, +103.0 favourable. Driver not evidenced in the documents: Commercial Director to comment. April was restated for a £620k cut-off correction on this line (Monthly Report - Apr-26 v2 FINAL); no document links it to May's variance. (Source: signed Variance Report - May-26; Monthly Report - Apr-26 v2 FINAL.)</a:t>
             </a:r>
           </a:p>
           <a:p>
@@ -4855,7 +5464,7 @@
               <a:defRPr sz="1200"/>
             </a:pPr>
             <a:r>
-              <a:t>Industrial Consumables &amp; Packaging: actual 8,464 against budget 8,361, +103.0 (£'000). Driver not evidenced in the documents: Commercial Director to comment (Variance Report - May-26 SIGNED KL.xlsx).</a:t>
+              <a:t>Cost of goods sold: 15,843 against budget 15,599, +244.0 adverse. Driver not evidenced in the documents: Head of Procurement to comment. (Source: signed Variance Report - May-26, commentary sheet.)</a:t>
             </a:r>
           </a:p>
           <a:p>
@@ -4863,7 +5472,7 @@
               <a:defRPr sz="1200"/>
             </a:pPr>
             <a:r>
-              <a:t>Cost of goods sold: actual 15,843 against budget 15,599, +244.0 (£'000). Driver not evidenced in the documents: Head of Procurement to comment (Variance Report - May-26 SIGNED KL.xlsx).</a:t>
+              <a:t>Bank: the operating account agrees to the cashbook at 8,911,388.92 as at 31 May 2026, against a statement balance of 9,882,613.23. Cheque 004182 (Airedale Window Cleaning, -1,850.00) is to be stopped and reissued, as decided by KL at sign-off. (Source: signed Bank Reconciliation - Operating Account - May-26.)</a:t>
             </a:r>
           </a:p>
         </p:txBody>
@@ -4947,7 +5556,7 @@
               <a:defRPr sz="1200"/>
             </a:pPr>
             <a:r>
-              <a:t>step1: signed 2026-10-18T11:26:14+00:00 by KL (sha256 44fc053f059d…)</a:t>
+              <a:t>step1: signed 2026-10-18T14:26:24+00:00 by KL (sha256 44fc053f059d…)</a:t>
             </a:r>
           </a:p>
           <a:p>
@@ -4955,7 +5564,7 @@
               <a:defRPr sz="1200"/>
             </a:pPr>
             <a:r>
-              <a:t>step2: signed 2026-10-18T11:26:40+00:00 by KL (sha256 9e007c8f0143…)</a:t>
+              <a:t>step2: signed 2026-10-18T14:27:01+00:00 by KL (sha256 0babe2ffeeec…)</a:t>
             </a:r>
           </a:p>
           <a:p>
@@ -4963,7 +5572,7 @@
               <a:defRPr sz="1200"/>
             </a:pPr>
             <a:r>
-              <a:t>Units: variance figures in thousands; cash figures in full. Flag threshold ±100k.</a:t>
+              <a:t>Units: variance figures in thousands; cash figures in full. Variance = actual - budget; F/A = effect on profit. Flag threshold ±100k.</a:t>
             </a:r>
           </a:p>
         </p:txBody>

</xml_diff>